<commit_message>
update landing page and links
</commit_message>
<xml_diff>
--- a/public/uploads/metacih.pptx
+++ b/public/uploads/metacih.pptx
@@ -3039,7 +3039,7 @@
           <a:p>
             <a:fld id="{EB79F1B9-2465-2247-87AC-305EB1F1A3D4}" type="datetimeFigureOut">
               <a:rPr lang="en-DE" smtClean="0"/>
-              <a:t>02/17/2026</a:t>
+              <a:t>04/21/2026</a:t>
             </a:fld>
             <a:endParaRPr lang="en-DE"/>
           </a:p>
@@ -3239,7 +3239,7 @@
           <a:p>
             <a:fld id="{EB79F1B9-2465-2247-87AC-305EB1F1A3D4}" type="datetimeFigureOut">
               <a:rPr lang="en-DE" smtClean="0"/>
-              <a:t>02/17/2026</a:t>
+              <a:t>04/21/2026</a:t>
             </a:fld>
             <a:endParaRPr lang="en-DE"/>
           </a:p>
@@ -3449,7 +3449,7 @@
           <a:p>
             <a:fld id="{EB79F1B9-2465-2247-87AC-305EB1F1A3D4}" type="datetimeFigureOut">
               <a:rPr lang="en-DE" smtClean="0"/>
-              <a:t>02/17/2026</a:t>
+              <a:t>04/21/2026</a:t>
             </a:fld>
             <a:endParaRPr lang="en-DE"/>
           </a:p>
@@ -3649,7 +3649,7 @@
           <a:p>
             <a:fld id="{EB79F1B9-2465-2247-87AC-305EB1F1A3D4}" type="datetimeFigureOut">
               <a:rPr lang="en-DE" smtClean="0"/>
-              <a:t>02/17/2026</a:t>
+              <a:t>04/21/2026</a:t>
             </a:fld>
             <a:endParaRPr lang="en-DE"/>
           </a:p>
@@ -3925,7 +3925,7 @@
           <a:p>
             <a:fld id="{EB79F1B9-2465-2247-87AC-305EB1F1A3D4}" type="datetimeFigureOut">
               <a:rPr lang="en-DE" smtClean="0"/>
-              <a:t>02/17/2026</a:t>
+              <a:t>04/21/2026</a:t>
             </a:fld>
             <a:endParaRPr lang="en-DE"/>
           </a:p>
@@ -4193,7 +4193,7 @@
           <a:p>
             <a:fld id="{EB79F1B9-2465-2247-87AC-305EB1F1A3D4}" type="datetimeFigureOut">
               <a:rPr lang="en-DE" smtClean="0"/>
-              <a:t>02/17/2026</a:t>
+              <a:t>04/21/2026</a:t>
             </a:fld>
             <a:endParaRPr lang="en-DE"/>
           </a:p>
@@ -4608,7 +4608,7 @@
           <a:p>
             <a:fld id="{EB79F1B9-2465-2247-87AC-305EB1F1A3D4}" type="datetimeFigureOut">
               <a:rPr lang="en-DE" smtClean="0"/>
-              <a:t>02/17/2026</a:t>
+              <a:t>04/21/2026</a:t>
             </a:fld>
             <a:endParaRPr lang="en-DE"/>
           </a:p>
@@ -4750,7 +4750,7 @@
           <a:p>
             <a:fld id="{EB79F1B9-2465-2247-87AC-305EB1F1A3D4}" type="datetimeFigureOut">
               <a:rPr lang="en-DE" smtClean="0"/>
-              <a:t>02/17/2026</a:t>
+              <a:t>04/21/2026</a:t>
             </a:fld>
             <a:endParaRPr lang="en-DE"/>
           </a:p>
@@ -4863,7 +4863,7 @@
           <a:p>
             <a:fld id="{EB79F1B9-2465-2247-87AC-305EB1F1A3D4}" type="datetimeFigureOut">
               <a:rPr lang="en-DE" smtClean="0"/>
-              <a:t>02/17/2026</a:t>
+              <a:t>04/21/2026</a:t>
             </a:fld>
             <a:endParaRPr lang="en-DE"/>
           </a:p>
@@ -5176,7 +5176,7 @@
           <a:p>
             <a:fld id="{EB79F1B9-2465-2247-87AC-305EB1F1A3D4}" type="datetimeFigureOut">
               <a:rPr lang="en-DE" smtClean="0"/>
-              <a:t>02/17/2026</a:t>
+              <a:t>04/21/2026</a:t>
             </a:fld>
             <a:endParaRPr lang="en-DE"/>
           </a:p>
@@ -5465,7 +5465,7 @@
           <a:p>
             <a:fld id="{EB79F1B9-2465-2247-87AC-305EB1F1A3D4}" type="datetimeFigureOut">
               <a:rPr lang="en-DE" smtClean="0"/>
-              <a:t>02/17/2026</a:t>
+              <a:t>04/21/2026</a:t>
             </a:fld>
             <a:endParaRPr lang="en-DE"/>
           </a:p>
@@ -5708,7 +5708,7 @@
           <a:p>
             <a:fld id="{EB79F1B9-2465-2247-87AC-305EB1F1A3D4}" type="datetimeFigureOut">
               <a:rPr lang="en-DE" smtClean="0"/>
-              <a:t>02/17/2026</a:t>
+              <a:t>04/21/2026</a:t>
             </a:fld>
             <a:endParaRPr lang="en-DE"/>
           </a:p>
@@ -7428,10 +7428,10 @@
       </p:sp>
       <p:grpSp>
         <p:nvGrpSpPr>
-          <p:cNvPr id="102" name="Group 101">
-            <a:extLst>
-              <a:ext uri="{FF2B5EF4-FFF2-40B4-BE49-F238E27FC236}">
-                <a16:creationId xmlns:a16="http://schemas.microsoft.com/office/drawing/2014/main" id="{F491A015-1C4F-A348-95DB-F9B658568716}"/>
+          <p:cNvPr id="103" name="Group 102">
+            <a:extLst>
+              <a:ext uri="{FF2B5EF4-FFF2-40B4-BE49-F238E27FC236}">
+                <a16:creationId xmlns:a16="http://schemas.microsoft.com/office/drawing/2014/main" id="{18B67898-35DD-B642-86B8-825FA915D91E}"/>
               </a:ext>
             </a:extLst>
           </p:cNvPr>
@@ -7440,148 +7440,7 @@
         </p:nvGrpSpPr>
         <p:grpSpPr>
           <a:xfrm>
-            <a:off x="2687309" y="3881882"/>
-            <a:ext cx="1855304" cy="1308847"/>
-            <a:chOff x="2647076" y="3480667"/>
-            <a:chExt cx="1855304" cy="1308847"/>
-          </a:xfrm>
-        </p:grpSpPr>
-        <p:grpSp>
-          <p:nvGrpSpPr>
-            <p:cNvPr id="10" name="Group 9">
-              <a:extLst>
-                <a:ext uri="{FF2B5EF4-FFF2-40B4-BE49-F238E27FC236}">
-                  <a16:creationId xmlns:a16="http://schemas.microsoft.com/office/drawing/2014/main" id="{231D3313-E792-8A42-88F3-622B19FE2C67}"/>
-                </a:ext>
-              </a:extLst>
-            </p:cNvPr>
-            <p:cNvGrpSpPr/>
-            <p:nvPr/>
-          </p:nvGrpSpPr>
-          <p:grpSpPr>
-            <a:xfrm>
-              <a:off x="3147730" y="3480667"/>
-              <a:ext cx="1072964" cy="924640"/>
-              <a:chOff x="3883319" y="2759807"/>
-              <a:chExt cx="1072964" cy="924640"/>
-            </a:xfrm>
-          </p:grpSpPr>
-          <p:pic>
-            <p:nvPicPr>
-              <p:cNvPr id="9" name="Picture 8" descr="Shape&#10;&#10;Description automatically generated with low confidence">
-                <a:extLst>
-                  <a:ext uri="{FF2B5EF4-FFF2-40B4-BE49-F238E27FC236}">
-                    <a16:creationId xmlns:a16="http://schemas.microsoft.com/office/drawing/2014/main" id="{238816EA-6250-BA44-BA66-9B5EE50F86A8}"/>
-                  </a:ext>
-                </a:extLst>
-              </p:cNvPr>
-              <p:cNvPicPr>
-                <a:picLocks noChangeAspect="1"/>
-              </p:cNvPicPr>
-              <p:nvPr/>
-            </p:nvPicPr>
-            <p:blipFill>
-              <a:blip r:embed="rId8"/>
-              <a:stretch>
-                <a:fillRect/>
-              </a:stretch>
-            </p:blipFill>
-            <p:spPr>
-              <a:xfrm>
-                <a:off x="3883319" y="2759807"/>
-                <a:ext cx="827492" cy="827492"/>
-              </a:xfrm>
-              <a:prstGeom prst="rect">
-                <a:avLst/>
-              </a:prstGeom>
-            </p:spPr>
-          </p:pic>
-          <p:pic>
-            <p:nvPicPr>
-              <p:cNvPr id="7" name="Picture 6">
-                <a:extLst>
-                  <a:ext uri="{FF2B5EF4-FFF2-40B4-BE49-F238E27FC236}">
-                    <a16:creationId xmlns:a16="http://schemas.microsoft.com/office/drawing/2014/main" id="{53283A8F-404B-DE48-86DE-E25D17DDD8E6}"/>
-                  </a:ext>
-                </a:extLst>
-              </p:cNvPr>
-              <p:cNvPicPr>
-                <a:picLocks noChangeAspect="1"/>
-              </p:cNvPicPr>
-              <p:nvPr/>
-            </p:nvPicPr>
-            <p:blipFill>
-              <a:blip r:embed="rId9"/>
-              <a:stretch>
-                <a:fillRect/>
-              </a:stretch>
-            </p:blipFill>
-            <p:spPr>
-              <a:xfrm>
-                <a:off x="4297065" y="3173553"/>
-                <a:ext cx="659218" cy="510894"/>
-              </a:xfrm>
-              <a:prstGeom prst="rect">
-                <a:avLst/>
-              </a:prstGeom>
-            </p:spPr>
-          </p:pic>
-        </p:grpSp>
-        <p:sp>
-          <p:nvSpPr>
-            <p:cNvPr id="101" name="TextBox 100">
-              <a:extLst>
-                <a:ext uri="{FF2B5EF4-FFF2-40B4-BE49-F238E27FC236}">
-                  <a16:creationId xmlns:a16="http://schemas.microsoft.com/office/drawing/2014/main" id="{492B5408-CA99-5547-B1DF-2C704CD3971D}"/>
-                </a:ext>
-              </a:extLst>
-            </p:cNvPr>
-            <p:cNvSpPr txBox="1"/>
-            <p:nvPr/>
-          </p:nvSpPr>
-          <p:spPr>
-            <a:xfrm>
-              <a:off x="2647076" y="4481737"/>
-              <a:ext cx="1855304" cy="307777"/>
-            </a:xfrm>
-            <a:prstGeom prst="rect">
-              <a:avLst/>
-            </a:prstGeom>
-            <a:noFill/>
-          </p:spPr>
-          <p:txBody>
-            <a:bodyPr wrap="square">
-              <a:spAutoFit/>
-            </a:bodyPr>
-            <a:lstStyle/>
-            <a:p>
-              <a:pPr algn="ctr"/>
-              <a:r>
-                <a:rPr lang="en-DE" sz="1400" b="1" dirty="0">
-                  <a:latin typeface="Fira Code" panose="020B0809050000020004" pitchFamily="49" charset="0"/>
-                  <a:ea typeface="Fira Code" panose="020B0809050000020004" pitchFamily="49" charset="0"/>
-                </a:rPr>
-                <a:t>metapsyData</a:t>
-              </a:r>
-            </a:p>
-          </p:txBody>
-        </p:sp>
-      </p:grpSp>
-      <p:grpSp>
-        <p:nvGrpSpPr>
-          <p:cNvPr id="103" name="Group 102">
-            <a:extLst>
-              <a:ext uri="{FF2B5EF4-FFF2-40B4-BE49-F238E27FC236}">
-                <a16:creationId xmlns:a16="http://schemas.microsoft.com/office/drawing/2014/main" id="{18B67898-35DD-B642-86B8-825FA915D91E}"/>
-              </a:ext>
-            </a:extLst>
-          </p:cNvPr>
-          <p:cNvGrpSpPr/>
-          <p:nvPr/>
-        </p:nvGrpSpPr>
-        <p:grpSpPr>
-          <a:xfrm>
-            <a:off x="5477605" y="3881882"/>
+            <a:off x="2904405" y="3881882"/>
             <a:ext cx="1855304" cy="1524290"/>
             <a:chOff x="2647076" y="3480667"/>
             <a:chExt cx="1855304" cy="1524290"/>
@@ -7743,7 +7602,7 @@
         </p:nvGrpSpPr>
         <p:grpSpPr>
           <a:xfrm>
-            <a:off x="8570060" y="3867113"/>
+            <a:off x="7042242" y="3867113"/>
             <a:ext cx="1768433" cy="1524290"/>
             <a:chOff x="7521237" y="3548638"/>
             <a:chExt cx="1768433" cy="1524290"/>
@@ -7892,8 +7751,8 @@
         </p:nvSpPr>
         <p:spPr>
           <a:xfrm>
-            <a:off x="4019828" y="3001125"/>
-            <a:ext cx="1109599" cy="307777"/>
+            <a:off x="3975747" y="3001125"/>
+            <a:ext cx="1197764" cy="307777"/>
           </a:xfrm>
           <a:prstGeom prst="rect">
             <a:avLst/>
@@ -7908,13 +7767,40 @@
           <a:p>
             <a:pPr algn="ctr"/>
             <a:r>
+              <a:rPr lang="en-DE" sz="1400" b="1" dirty="0" smtClean="0">
+                <a:solidFill>
+                  <a:srgbClr val="10775F"/>
+                </a:solidFill>
+                <a:latin typeface="Fira Sans" panose="020B0503050000020004" pitchFamily="34" charset="0"/>
+              </a:rPr>
+              <a:t>A</a:t>
+            </a:r>
+            <a:r>
+              <a:rPr lang="de-DE" sz="1400" b="1" dirty="0" err="1" smtClean="0">
+                <a:solidFill>
+                  <a:srgbClr val="10775F"/>
+                </a:solidFill>
+                <a:latin typeface="Fira Sans" panose="020B0503050000020004" pitchFamily="34" charset="0"/>
+              </a:rPr>
+              <a:t>nalyze</a:t>
+            </a:r>
+            <a:r>
+              <a:rPr lang="en-DE" sz="1400" b="1" dirty="0" smtClean="0">
+                <a:solidFill>
+                  <a:srgbClr val="10775F"/>
+                </a:solidFill>
+                <a:latin typeface="Fira Sans" panose="020B0503050000020004" pitchFamily="34" charset="0"/>
+              </a:rPr>
+              <a:t> </a:t>
+            </a:r>
+            <a:r>
               <a:rPr lang="en-DE" sz="1400" b="1" dirty="0">
                 <a:solidFill>
                   <a:srgbClr val="10775F"/>
                 </a:solidFill>
                 <a:latin typeface="Fira Sans" panose="020B0503050000020004" pitchFamily="34" charset="0"/>
               </a:rPr>
-              <a:t>Access in R</a:t>
+              <a:t>in R</a:t>
             </a:r>
           </a:p>
         </p:txBody>
@@ -7930,19 +7816,17 @@
           </p:cNvPr>
           <p:cNvCxnSpPr>
             <a:cxnSpLocks/>
-            <a:stCxn id="53" idx="2"/>
-            <a:endCxn id="6" idx="0"/>
           </p:cNvCxnSpPr>
           <p:nvPr/>
         </p:nvCxnSpPr>
         <p:spPr>
           <a:xfrm rot="16200000" flipH="1">
-            <a:off x="6845245" y="1258080"/>
-            <a:ext cx="1457948" cy="3760118"/>
+            <a:off x="6010986" y="2092339"/>
+            <a:ext cx="1457948" cy="2091600"/>
           </a:xfrm>
           <a:prstGeom prst="bentConnector3">
             <a:avLst>
-              <a:gd name="adj1" fmla="val 62725"/>
+              <a:gd name="adj1" fmla="val 62481"/>
             </a:avLst>
           </a:prstGeom>
           <a:ln w="28575">
@@ -7981,7 +7865,7 @@
         </p:nvSpPr>
         <p:spPr>
           <a:xfrm>
-            <a:off x="7114580" y="3020130"/>
+            <a:off x="6007140" y="3020130"/>
             <a:ext cx="1438214" cy="307777"/>
           </a:xfrm>
           <a:prstGeom prst="rect">
@@ -8004,93 +7888,6 @@
                 <a:latin typeface="Fira Sans" panose="020B0503050000020004" pitchFamily="34" charset="0"/>
               </a:rPr>
               <a:t>Analyze Online</a:t>
-            </a:r>
-          </a:p>
-        </p:txBody>
-      </p:sp>
-      <p:cxnSp>
-        <p:nvCxnSpPr>
-          <p:cNvPr id="130" name="Elbow Connector 129">
-            <a:extLst>
-              <a:ext uri="{FF2B5EF4-FFF2-40B4-BE49-F238E27FC236}">
-                <a16:creationId xmlns:a16="http://schemas.microsoft.com/office/drawing/2014/main" id="{92F8E4EA-7FD0-414D-A6D5-6D8006F664AA}"/>
-              </a:ext>
-            </a:extLst>
-          </p:cNvPr>
-          <p:cNvCxnSpPr>
-            <a:cxnSpLocks/>
-          </p:cNvCxnSpPr>
-          <p:nvPr/>
-        </p:nvCxnSpPr>
-        <p:spPr>
-          <a:xfrm rot="16200000" flipH="1">
-            <a:off x="4902389" y="3903303"/>
-            <a:ext cx="215443" cy="2790296"/>
-          </a:xfrm>
-          <a:prstGeom prst="bentConnector3">
-            <a:avLst>
-              <a:gd name="adj1" fmla="val 347583"/>
-            </a:avLst>
-          </a:prstGeom>
-          <a:ln w="28575">
-            <a:solidFill>
-              <a:srgbClr val="10775F"/>
-            </a:solidFill>
-            <a:tailEnd type="triangle"/>
-          </a:ln>
-        </p:spPr>
-        <p:style>
-          <a:lnRef idx="1">
-            <a:schemeClr val="accent1"/>
-          </a:lnRef>
-          <a:fillRef idx="0">
-            <a:schemeClr val="accent1"/>
-          </a:fillRef>
-          <a:effectRef idx="0">
-            <a:schemeClr val="accent1"/>
-          </a:effectRef>
-          <a:fontRef idx="minor">
-            <a:schemeClr val="tx1"/>
-          </a:fontRef>
-        </p:style>
-      </p:cxnSp>
-      <p:sp>
-        <p:nvSpPr>
-          <p:cNvPr id="134" name="TextBox 133">
-            <a:extLst>
-              <a:ext uri="{FF2B5EF4-FFF2-40B4-BE49-F238E27FC236}">
-                <a16:creationId xmlns:a16="http://schemas.microsoft.com/office/drawing/2014/main" id="{F29211C2-02CB-474C-A0A7-46D9F5B68FEA}"/>
-              </a:ext>
-            </a:extLst>
-          </p:cNvPr>
-          <p:cNvSpPr txBox="1"/>
-          <p:nvPr/>
-        </p:nvSpPr>
-        <p:spPr>
-          <a:xfrm>
-            <a:off x="4331054" y="5621615"/>
-            <a:ext cx="1197764" cy="307777"/>
-          </a:xfrm>
-          <a:prstGeom prst="rect">
-            <a:avLst/>
-          </a:prstGeom>
-          <a:noFill/>
-        </p:spPr>
-        <p:txBody>
-          <a:bodyPr wrap="none" rtlCol="0">
-            <a:spAutoFit/>
-          </a:bodyPr>
-          <a:lstStyle/>
-          <a:p>
-            <a:pPr algn="ctr"/>
-            <a:r>
-              <a:rPr lang="en-DE" sz="1400" b="1" dirty="0">
-                <a:solidFill>
-                  <a:srgbClr val="10775F"/>
-                </a:solidFill>
-                <a:latin typeface="Fira Sans" panose="020B0503050000020004" pitchFamily="34" charset="0"/>
-              </a:rPr>
-              <a:t>Analyze in R</a:t>
             </a:r>
           </a:p>
         </p:txBody>
@@ -8155,6 +7952,160 @@
           <a:chExt cx="0" cy="0"/>
         </a:xfrm>
       </p:grpSpPr>
+      <p:cxnSp>
+        <p:nvCxnSpPr>
+          <p:cNvPr id="60" name="Elbow Connector 123">
+            <a:extLst>
+              <a:ext uri="{FF2B5EF4-FFF2-40B4-BE49-F238E27FC236}">
+                <a16:creationId xmlns:a16="http://schemas.microsoft.com/office/drawing/2014/main" id="{94A58F50-CF6A-B44E-83A9-53ADDB94F940}"/>
+              </a:ext>
+            </a:extLst>
+          </p:cNvPr>
+          <p:cNvCxnSpPr>
+            <a:cxnSpLocks/>
+          </p:cNvCxnSpPr>
+          <p:nvPr/>
+        </p:nvCxnSpPr>
+        <p:spPr>
+          <a:xfrm rot="16200000" flipH="1">
+            <a:off x="6010986" y="2092339"/>
+            <a:ext cx="1457948" cy="2091600"/>
+          </a:xfrm>
+          <a:prstGeom prst="bentConnector3">
+            <a:avLst>
+              <a:gd name="adj1" fmla="val 62481"/>
+            </a:avLst>
+          </a:prstGeom>
+          <a:ln w="28575">
+            <a:solidFill>
+              <a:srgbClr val="D0CECE"/>
+            </a:solidFill>
+            <a:tailEnd type="triangle"/>
+          </a:ln>
+        </p:spPr>
+        <p:style>
+          <a:lnRef idx="1">
+            <a:schemeClr val="accent1"/>
+          </a:lnRef>
+          <a:fillRef idx="0">
+            <a:schemeClr val="accent1"/>
+          </a:fillRef>
+          <a:effectRef idx="0">
+            <a:schemeClr val="accent1"/>
+          </a:effectRef>
+          <a:fontRef idx="minor">
+            <a:schemeClr val="tx1"/>
+          </a:fontRef>
+        </p:style>
+      </p:cxnSp>
+      <p:grpSp>
+        <p:nvGrpSpPr>
+          <p:cNvPr id="109" name="Group 108">
+            <a:extLst>
+              <a:ext uri="{FF2B5EF4-FFF2-40B4-BE49-F238E27FC236}">
+                <a16:creationId xmlns:a16="http://schemas.microsoft.com/office/drawing/2014/main" id="{24F1D788-349B-1140-AD1D-64B64A4E5641}"/>
+              </a:ext>
+            </a:extLst>
+          </p:cNvPr>
+          <p:cNvGrpSpPr/>
+          <p:nvPr/>
+        </p:nvGrpSpPr>
+        <p:grpSpPr>
+          <a:xfrm>
+            <a:off x="7225570" y="3881882"/>
+            <a:ext cx="1768433" cy="1524290"/>
+            <a:chOff x="7521237" y="3548638"/>
+            <a:chExt cx="1768433" cy="1524290"/>
+          </a:xfrm>
+        </p:grpSpPr>
+        <p:pic>
+          <p:nvPicPr>
+            <p:cNvPr id="6" name="Picture 5" descr="Shape&#10;&#10;Description automatically generated with low confidence">
+              <a:extLst>
+                <a:ext uri="{FF2B5EF4-FFF2-40B4-BE49-F238E27FC236}">
+                  <a16:creationId xmlns:a16="http://schemas.microsoft.com/office/drawing/2014/main" id="{6515DA33-2386-F34D-95A6-1DDAC82AA865}"/>
+                </a:ext>
+              </a:extLst>
+            </p:cNvPr>
+            <p:cNvPicPr>
+              <a:picLocks noChangeAspect="1"/>
+            </p:cNvPicPr>
+            <p:nvPr/>
+          </p:nvPicPr>
+          <p:blipFill>
+            <a:blip r:embed="rId2"/>
+            <a:stretch>
+              <a:fillRect/>
+            </a:stretch>
+          </p:blipFill>
+          <p:spPr>
+            <a:xfrm>
+              <a:off x="7991709" y="3548638"/>
+              <a:ext cx="827491" cy="827491"/>
+            </a:xfrm>
+            <a:prstGeom prst="rect">
+              <a:avLst/>
+            </a:prstGeom>
+          </p:spPr>
+        </p:pic>
+        <p:sp>
+          <p:nvSpPr>
+            <p:cNvPr id="108" name="TextBox 107">
+              <a:extLst>
+                <a:ext uri="{FF2B5EF4-FFF2-40B4-BE49-F238E27FC236}">
+                  <a16:creationId xmlns:a16="http://schemas.microsoft.com/office/drawing/2014/main" id="{4F73CE22-A2A8-FE44-A093-C4C6B55C9580}"/>
+                </a:ext>
+              </a:extLst>
+            </p:cNvPr>
+            <p:cNvSpPr txBox="1"/>
+            <p:nvPr/>
+          </p:nvSpPr>
+          <p:spPr>
+            <a:xfrm>
+              <a:off x="7521237" y="4549708"/>
+              <a:ext cx="1768433" cy="523220"/>
+            </a:xfrm>
+            <a:prstGeom prst="rect">
+              <a:avLst/>
+            </a:prstGeom>
+            <a:noFill/>
+          </p:spPr>
+          <p:txBody>
+            <a:bodyPr wrap="none" rtlCol="0">
+              <a:spAutoFit/>
+            </a:bodyPr>
+            <a:lstStyle/>
+            <a:p>
+              <a:pPr algn="ctr"/>
+              <a:r>
+                <a:rPr lang="en-DE" sz="1400" b="1" dirty="0">
+                  <a:solidFill>
+                    <a:schemeClr val="bg2">
+                      <a:lumMod val="75000"/>
+                    </a:schemeClr>
+                  </a:solidFill>
+                  <a:latin typeface="Fira Sans" panose="020B0503050000020004" pitchFamily="34" charset="0"/>
+                </a:rPr>
+                <a:t>Meta-Analysis Tool</a:t>
+              </a:r>
+            </a:p>
+            <a:p>
+              <a:pPr algn="ctr"/>
+              <a:r>
+                <a:rPr lang="en-DE" sz="1400" dirty="0">
+                  <a:solidFill>
+                    <a:schemeClr val="bg2">
+                      <a:lumMod val="75000"/>
+                    </a:schemeClr>
+                  </a:solidFill>
+                  <a:latin typeface="Fira Sans" panose="020B0503050000020004" pitchFamily="34" charset="0"/>
+                </a:rPr>
+                <a:t>metapsy.org</a:t>
+              </a:r>
+            </a:p>
+          </p:txBody>
+        </p:sp>
+      </p:grpSp>
       <p:pic>
         <p:nvPicPr>
           <p:cNvPr id="13" name="Picture 12" descr="Shape&#10;&#10;Description automatically generated with low confidence">
@@ -8170,7 +8121,7 @@
           <p:nvPr/>
         </p:nvPicPr>
         <p:blipFill>
-          <a:blip r:embed="rId2"/>
+          <a:blip r:embed="rId3"/>
           <a:stretch>
             <a:fillRect/>
           </a:stretch>
@@ -8294,7 +8245,7 @@
             <p:nvPr/>
           </p:nvPicPr>
           <p:blipFill>
-            <a:blip r:embed="rId3"/>
+            <a:blip r:embed="rId4"/>
             <a:stretch>
               <a:fillRect/>
             </a:stretch>
@@ -8422,7 +8373,7 @@
               <p:nvPr/>
             </p:nvPicPr>
             <p:blipFill>
-              <a:blip r:embed="rId4">
+              <a:blip r:embed="rId5">
                 <a:grayscl/>
               </a:blip>
               <a:stretch>
@@ -8454,7 +8405,7 @@
               <p:nvPr/>
             </p:nvPicPr>
             <p:blipFill>
-              <a:blip r:embed="rId5"/>
+              <a:blip r:embed="rId6"/>
               <a:stretch>
                 <a:fillRect/>
               </a:stretch>
@@ -8800,7 +8751,7 @@
             <p:nvPr/>
           </p:nvPicPr>
           <p:blipFill>
-            <a:blip r:embed="rId6"/>
+            <a:blip r:embed="rId7"/>
             <a:stretch>
               <a:fillRect/>
             </a:stretch>
@@ -8830,7 +8781,7 @@
             <p:nvPr/>
           </p:nvPicPr>
           <p:blipFill>
-            <a:blip r:embed="rId6"/>
+            <a:blip r:embed="rId7"/>
             <a:stretch>
               <a:fillRect/>
             </a:stretch>
@@ -8860,7 +8811,7 @@
             <p:nvPr/>
           </p:nvPicPr>
           <p:blipFill>
-            <a:blip r:embed="rId6"/>
+            <a:blip r:embed="rId7"/>
             <a:stretch>
               <a:fillRect/>
             </a:stretch>
@@ -8890,7 +8841,7 @@
             <p:nvPr/>
           </p:nvPicPr>
           <p:blipFill>
-            <a:blip r:embed="rId6"/>
+            <a:blip r:embed="rId7"/>
             <a:stretch>
               <a:fillRect/>
             </a:stretch>
@@ -8920,7 +8871,7 @@
             <p:nvPr/>
           </p:nvPicPr>
           <p:blipFill>
-            <a:blip r:embed="rId6"/>
+            <a:blip r:embed="rId7"/>
             <a:stretch>
               <a:fillRect/>
             </a:stretch>
@@ -9319,7 +9270,7 @@
             <p:nvPr/>
           </p:nvPicPr>
           <p:blipFill>
-            <a:blip r:embed="rId7"/>
+            <a:blip r:embed="rId8"/>
             <a:stretch>
               <a:fillRect/>
             </a:stretch>
@@ -9526,10 +9477,10 @@
       </p:sp>
       <p:grpSp>
         <p:nvGrpSpPr>
-          <p:cNvPr id="102" name="Group 101">
-            <a:extLst>
-              <a:ext uri="{FF2B5EF4-FFF2-40B4-BE49-F238E27FC236}">
-                <a16:creationId xmlns:a16="http://schemas.microsoft.com/office/drawing/2014/main" id="{F491A015-1C4F-A348-95DB-F9B658568716}"/>
+          <p:cNvPr id="103" name="Group 102">
+            <a:extLst>
+              <a:ext uri="{FF2B5EF4-FFF2-40B4-BE49-F238E27FC236}">
+                <a16:creationId xmlns:a16="http://schemas.microsoft.com/office/drawing/2014/main" id="{18B67898-35DD-B642-86B8-825FA915D91E}"/>
               </a:ext>
             </a:extLst>
           </p:cNvPr>
@@ -9538,148 +9489,7 @@
         </p:nvGrpSpPr>
         <p:grpSpPr>
           <a:xfrm>
-            <a:off x="2687309" y="3881882"/>
-            <a:ext cx="1855304" cy="1308847"/>
-            <a:chOff x="2647076" y="3480667"/>
-            <a:chExt cx="1855304" cy="1308847"/>
-          </a:xfrm>
-        </p:grpSpPr>
-        <p:grpSp>
-          <p:nvGrpSpPr>
-            <p:cNvPr id="10" name="Group 9">
-              <a:extLst>
-                <a:ext uri="{FF2B5EF4-FFF2-40B4-BE49-F238E27FC236}">
-                  <a16:creationId xmlns:a16="http://schemas.microsoft.com/office/drawing/2014/main" id="{231D3313-E792-8A42-88F3-622B19FE2C67}"/>
-                </a:ext>
-              </a:extLst>
-            </p:cNvPr>
-            <p:cNvGrpSpPr/>
-            <p:nvPr/>
-          </p:nvGrpSpPr>
-          <p:grpSpPr>
-            <a:xfrm>
-              <a:off x="3147730" y="3480667"/>
-              <a:ext cx="1072964" cy="924640"/>
-              <a:chOff x="3883319" y="2759807"/>
-              <a:chExt cx="1072964" cy="924640"/>
-            </a:xfrm>
-          </p:grpSpPr>
-          <p:pic>
-            <p:nvPicPr>
-              <p:cNvPr id="9" name="Picture 8" descr="Shape&#10;&#10;Description automatically generated with low confidence">
-                <a:extLst>
-                  <a:ext uri="{FF2B5EF4-FFF2-40B4-BE49-F238E27FC236}">
-                    <a16:creationId xmlns:a16="http://schemas.microsoft.com/office/drawing/2014/main" id="{238816EA-6250-BA44-BA66-9B5EE50F86A8}"/>
-                  </a:ext>
-                </a:extLst>
-              </p:cNvPr>
-              <p:cNvPicPr>
-                <a:picLocks noChangeAspect="1"/>
-              </p:cNvPicPr>
-              <p:nvPr/>
-            </p:nvPicPr>
-            <p:blipFill>
-              <a:blip r:embed="rId8"/>
-              <a:stretch>
-                <a:fillRect/>
-              </a:stretch>
-            </p:blipFill>
-            <p:spPr>
-              <a:xfrm>
-                <a:off x="3883319" y="2759807"/>
-                <a:ext cx="827492" cy="827492"/>
-              </a:xfrm>
-              <a:prstGeom prst="rect">
-                <a:avLst/>
-              </a:prstGeom>
-            </p:spPr>
-          </p:pic>
-          <p:pic>
-            <p:nvPicPr>
-              <p:cNvPr id="7" name="Picture 6">
-                <a:extLst>
-                  <a:ext uri="{FF2B5EF4-FFF2-40B4-BE49-F238E27FC236}">
-                    <a16:creationId xmlns:a16="http://schemas.microsoft.com/office/drawing/2014/main" id="{53283A8F-404B-DE48-86DE-E25D17DDD8E6}"/>
-                  </a:ext>
-                </a:extLst>
-              </p:cNvPr>
-              <p:cNvPicPr>
-                <a:picLocks noChangeAspect="1"/>
-              </p:cNvPicPr>
-              <p:nvPr/>
-            </p:nvPicPr>
-            <p:blipFill>
-              <a:blip r:embed="rId9"/>
-              <a:stretch>
-                <a:fillRect/>
-              </a:stretch>
-            </p:blipFill>
-            <p:spPr>
-              <a:xfrm>
-                <a:off x="4297065" y="3173553"/>
-                <a:ext cx="659218" cy="510894"/>
-              </a:xfrm>
-              <a:prstGeom prst="rect">
-                <a:avLst/>
-              </a:prstGeom>
-            </p:spPr>
-          </p:pic>
-        </p:grpSp>
-        <p:sp>
-          <p:nvSpPr>
-            <p:cNvPr id="101" name="TextBox 100">
-              <a:extLst>
-                <a:ext uri="{FF2B5EF4-FFF2-40B4-BE49-F238E27FC236}">
-                  <a16:creationId xmlns:a16="http://schemas.microsoft.com/office/drawing/2014/main" id="{492B5408-CA99-5547-B1DF-2C704CD3971D}"/>
-                </a:ext>
-              </a:extLst>
-            </p:cNvPr>
-            <p:cNvSpPr txBox="1"/>
-            <p:nvPr/>
-          </p:nvSpPr>
-          <p:spPr>
-            <a:xfrm>
-              <a:off x="2647076" y="4481737"/>
-              <a:ext cx="1855304" cy="307777"/>
-            </a:xfrm>
-            <a:prstGeom prst="rect">
-              <a:avLst/>
-            </a:prstGeom>
-            <a:noFill/>
-          </p:spPr>
-          <p:txBody>
-            <a:bodyPr wrap="square">
-              <a:spAutoFit/>
-            </a:bodyPr>
-            <a:lstStyle/>
-            <a:p>
-              <a:pPr algn="ctr"/>
-              <a:r>
-                <a:rPr lang="en-DE" sz="1400" b="1" dirty="0">
-                  <a:latin typeface="Fira Code" panose="020B0809050000020004" pitchFamily="49" charset="0"/>
-                  <a:ea typeface="Fira Code" panose="020B0809050000020004" pitchFamily="49" charset="0"/>
-                </a:rPr>
-                <a:t>metapsyData</a:t>
-              </a:r>
-            </a:p>
-          </p:txBody>
-        </p:sp>
-      </p:grpSp>
-      <p:grpSp>
-        <p:nvGrpSpPr>
-          <p:cNvPr id="103" name="Group 102">
-            <a:extLst>
-              <a:ext uri="{FF2B5EF4-FFF2-40B4-BE49-F238E27FC236}">
-                <a16:creationId xmlns:a16="http://schemas.microsoft.com/office/drawing/2014/main" id="{18B67898-35DD-B642-86B8-825FA915D91E}"/>
-              </a:ext>
-            </a:extLst>
-          </p:cNvPr>
-          <p:cNvGrpSpPr/>
-          <p:nvPr/>
-        </p:nvGrpSpPr>
-        <p:grpSpPr>
-          <a:xfrm>
-            <a:off x="5477605" y="3881882"/>
+            <a:off x="2978245" y="3881882"/>
             <a:ext cx="1855304" cy="1524290"/>
             <a:chOff x="2647076" y="3480667"/>
             <a:chExt cx="1855304" cy="1524290"/>
@@ -9720,7 +9530,7 @@
               <p:nvPr/>
             </p:nvPicPr>
             <p:blipFill>
-              <a:blip r:embed="rId8"/>
+              <a:blip r:embed="rId9"/>
               <a:stretch>
                 <a:fillRect/>
               </a:stretch>
@@ -9750,7 +9560,7 @@
               <p:nvPr/>
             </p:nvPicPr>
             <p:blipFill>
-              <a:blip r:embed="rId9"/>
+              <a:blip r:embed="rId10"/>
               <a:stretch>
                 <a:fillRect/>
               </a:stretch>
@@ -9827,114 +9637,6 @@
           </p:txBody>
         </p:sp>
       </p:grpSp>
-      <p:grpSp>
-        <p:nvGrpSpPr>
-          <p:cNvPr id="109" name="Group 108">
-            <a:extLst>
-              <a:ext uri="{FF2B5EF4-FFF2-40B4-BE49-F238E27FC236}">
-                <a16:creationId xmlns:a16="http://schemas.microsoft.com/office/drawing/2014/main" id="{24F1D788-349B-1140-AD1D-64B64A4E5641}"/>
-              </a:ext>
-            </a:extLst>
-          </p:cNvPr>
-          <p:cNvGrpSpPr/>
-          <p:nvPr/>
-        </p:nvGrpSpPr>
-        <p:grpSpPr>
-          <a:xfrm>
-            <a:off x="8570060" y="3867113"/>
-            <a:ext cx="1768433" cy="1524290"/>
-            <a:chOff x="7521237" y="3548638"/>
-            <a:chExt cx="1768433" cy="1524290"/>
-          </a:xfrm>
-        </p:grpSpPr>
-        <p:pic>
-          <p:nvPicPr>
-            <p:cNvPr id="6" name="Picture 5" descr="Shape&#10;&#10;Description automatically generated with low confidence">
-              <a:extLst>
-                <a:ext uri="{FF2B5EF4-FFF2-40B4-BE49-F238E27FC236}">
-                  <a16:creationId xmlns:a16="http://schemas.microsoft.com/office/drawing/2014/main" id="{6515DA33-2386-F34D-95A6-1DDAC82AA865}"/>
-                </a:ext>
-              </a:extLst>
-            </p:cNvPr>
-            <p:cNvPicPr>
-              <a:picLocks noChangeAspect="1"/>
-            </p:cNvPicPr>
-            <p:nvPr/>
-          </p:nvPicPr>
-          <p:blipFill>
-            <a:blip r:embed="rId10"/>
-            <a:stretch>
-              <a:fillRect/>
-            </a:stretch>
-          </p:blipFill>
-          <p:spPr>
-            <a:xfrm>
-              <a:off x="7991709" y="3548638"/>
-              <a:ext cx="827491" cy="827491"/>
-            </a:xfrm>
-            <a:prstGeom prst="rect">
-              <a:avLst/>
-            </a:prstGeom>
-          </p:spPr>
-        </p:pic>
-        <p:sp>
-          <p:nvSpPr>
-            <p:cNvPr id="108" name="TextBox 107">
-              <a:extLst>
-                <a:ext uri="{FF2B5EF4-FFF2-40B4-BE49-F238E27FC236}">
-                  <a16:creationId xmlns:a16="http://schemas.microsoft.com/office/drawing/2014/main" id="{4F73CE22-A2A8-FE44-A093-C4C6B55C9580}"/>
-                </a:ext>
-              </a:extLst>
-            </p:cNvPr>
-            <p:cNvSpPr txBox="1"/>
-            <p:nvPr/>
-          </p:nvSpPr>
-          <p:spPr>
-            <a:xfrm>
-              <a:off x="7521237" y="4549708"/>
-              <a:ext cx="1768433" cy="523220"/>
-            </a:xfrm>
-            <a:prstGeom prst="rect">
-              <a:avLst/>
-            </a:prstGeom>
-            <a:noFill/>
-          </p:spPr>
-          <p:txBody>
-            <a:bodyPr wrap="none" rtlCol="0">
-              <a:spAutoFit/>
-            </a:bodyPr>
-            <a:lstStyle/>
-            <a:p>
-              <a:pPr algn="ctr"/>
-              <a:r>
-                <a:rPr lang="en-DE" sz="1400" b="1" dirty="0">
-                  <a:solidFill>
-                    <a:schemeClr val="bg2">
-                      <a:lumMod val="75000"/>
-                    </a:schemeClr>
-                  </a:solidFill>
-                  <a:latin typeface="Fira Sans" panose="020B0503050000020004" pitchFamily="34" charset="0"/>
-                </a:rPr>
-                <a:t>Meta-Analysis Tool</a:t>
-              </a:r>
-            </a:p>
-            <a:p>
-              <a:pPr algn="ctr"/>
-              <a:r>
-                <a:rPr lang="en-DE" sz="1400" dirty="0">
-                  <a:solidFill>
-                    <a:schemeClr val="bg2">
-                      <a:lumMod val="75000"/>
-                    </a:schemeClr>
-                  </a:solidFill>
-                  <a:latin typeface="Fira Sans" panose="020B0503050000020004" pitchFamily="34" charset="0"/>
-                </a:rPr>
-                <a:t>metapsy.org</a:t>
-              </a:r>
-            </a:p>
-          </p:txBody>
-        </p:sp>
-      </p:grpSp>
       <p:sp>
         <p:nvSpPr>
           <p:cNvPr id="113" name="TextBox 112">
@@ -9949,8 +9651,8 @@
         </p:nvSpPr>
         <p:spPr>
           <a:xfrm>
-            <a:off x="4019828" y="3001125"/>
-            <a:ext cx="1109599" cy="307777"/>
+            <a:off x="3925251" y="3001125"/>
+            <a:ext cx="1298753" cy="307777"/>
           </a:xfrm>
           <a:prstGeom prst="rect">
             <a:avLst/>
@@ -9965,106 +9667,40 @@
           <a:p>
             <a:pPr algn="ctr"/>
             <a:r>
+              <a:rPr lang="en-DE" sz="1400" b="1" dirty="0" smtClean="0">
+                <a:solidFill>
+                  <a:srgbClr val="10775F"/>
+                </a:solidFill>
+                <a:latin typeface="Fira Sans" panose="020B0503050000020004" pitchFamily="34" charset="0"/>
+              </a:rPr>
+              <a:t>A</a:t>
+            </a:r>
+            <a:r>
+              <a:rPr lang="de-DE" sz="1400" b="1" dirty="0" err="1" smtClean="0">
+                <a:solidFill>
+                  <a:srgbClr val="10775F"/>
+                </a:solidFill>
+                <a:latin typeface="Fira Sans" panose="020B0503050000020004" pitchFamily="34" charset="0"/>
+              </a:rPr>
+              <a:t>analyze</a:t>
+            </a:r>
+            <a:r>
+              <a:rPr lang="en-DE" sz="1400" b="1" dirty="0" smtClean="0">
+                <a:solidFill>
+                  <a:srgbClr val="10775F"/>
+                </a:solidFill>
+                <a:latin typeface="Fira Sans" panose="020B0503050000020004" pitchFamily="34" charset="0"/>
+              </a:rPr>
+              <a:t> </a:t>
+            </a:r>
+            <a:r>
               <a:rPr lang="en-DE" sz="1400" b="1" dirty="0">
                 <a:solidFill>
                   <a:srgbClr val="10775F"/>
                 </a:solidFill>
                 <a:latin typeface="Fira Sans" panose="020B0503050000020004" pitchFamily="34" charset="0"/>
               </a:rPr>
-              <a:t>Access in R</a:t>
-            </a:r>
-          </a:p>
-        </p:txBody>
-      </p:sp>
-      <p:cxnSp>
-        <p:nvCxnSpPr>
-          <p:cNvPr id="124" name="Elbow Connector 123">
-            <a:extLst>
-              <a:ext uri="{FF2B5EF4-FFF2-40B4-BE49-F238E27FC236}">
-                <a16:creationId xmlns:a16="http://schemas.microsoft.com/office/drawing/2014/main" id="{94A58F50-CF6A-B44E-83A9-53ADDB94F940}"/>
-              </a:ext>
-            </a:extLst>
-          </p:cNvPr>
-          <p:cNvCxnSpPr>
-            <a:cxnSpLocks/>
-            <a:stCxn id="53" idx="2"/>
-            <a:endCxn id="6" idx="0"/>
-          </p:cNvCxnSpPr>
-          <p:nvPr/>
-        </p:nvCxnSpPr>
-        <p:spPr>
-          <a:xfrm rot="16200000" flipH="1">
-            <a:off x="6845245" y="1258080"/>
-            <a:ext cx="1457948" cy="3760118"/>
-          </a:xfrm>
-          <a:prstGeom prst="bentConnector3">
-            <a:avLst>
-              <a:gd name="adj1" fmla="val 62725"/>
-            </a:avLst>
-          </a:prstGeom>
-          <a:ln w="28575">
-            <a:solidFill>
-              <a:schemeClr val="bg2">
-                <a:lumMod val="90000"/>
-              </a:schemeClr>
-            </a:solidFill>
-            <a:tailEnd type="triangle"/>
-          </a:ln>
-        </p:spPr>
-        <p:style>
-          <a:lnRef idx="1">
-            <a:schemeClr val="accent1"/>
-          </a:lnRef>
-          <a:fillRef idx="0">
-            <a:schemeClr val="accent1"/>
-          </a:fillRef>
-          <a:effectRef idx="0">
-            <a:schemeClr val="accent1"/>
-          </a:effectRef>
-          <a:fontRef idx="minor">
-            <a:schemeClr val="tx1"/>
-          </a:fontRef>
-        </p:style>
-      </p:cxnSp>
-      <p:sp>
-        <p:nvSpPr>
-          <p:cNvPr id="129" name="TextBox 128">
-            <a:extLst>
-              <a:ext uri="{FF2B5EF4-FFF2-40B4-BE49-F238E27FC236}">
-                <a16:creationId xmlns:a16="http://schemas.microsoft.com/office/drawing/2014/main" id="{7C745938-4E7D-694A-8CF7-43CC993F8C00}"/>
-              </a:ext>
-            </a:extLst>
-          </p:cNvPr>
-          <p:cNvSpPr txBox="1"/>
-          <p:nvPr/>
-        </p:nvSpPr>
-        <p:spPr>
-          <a:xfrm>
-            <a:off x="7114580" y="3020130"/>
-            <a:ext cx="1438214" cy="307777"/>
-          </a:xfrm>
-          <a:prstGeom prst="rect">
-            <a:avLst/>
-          </a:prstGeom>
-          <a:noFill/>
-        </p:spPr>
-        <p:txBody>
-          <a:bodyPr wrap="none" rtlCol="0">
-            <a:spAutoFit/>
-          </a:bodyPr>
-          <a:lstStyle/>
-          <a:p>
-            <a:pPr algn="ctr"/>
-            <a:r>
-              <a:rPr lang="en-DE" sz="1400" b="1" dirty="0">
-                <a:solidFill>
-                  <a:schemeClr val="bg2">
-                    <a:lumMod val="75000"/>
-                  </a:schemeClr>
-                </a:solidFill>
-                <a:latin typeface="Fira Sans" panose="020B0503050000020004" pitchFamily="34" charset="0"/>
-              </a:rPr>
-              <a:t>Analyze Online</a:t>
+              <a:t>in R</a:t>
             </a:r>
           </a:p>
         </p:txBody>
@@ -10117,93 +9753,6 @@
           </a:fontRef>
         </p:style>
       </p:cxnSp>
-      <p:cxnSp>
-        <p:nvCxnSpPr>
-          <p:cNvPr id="130" name="Elbow Connector 129">
-            <a:extLst>
-              <a:ext uri="{FF2B5EF4-FFF2-40B4-BE49-F238E27FC236}">
-                <a16:creationId xmlns:a16="http://schemas.microsoft.com/office/drawing/2014/main" id="{92F8E4EA-7FD0-414D-A6D5-6D8006F664AA}"/>
-              </a:ext>
-            </a:extLst>
-          </p:cNvPr>
-          <p:cNvCxnSpPr>
-            <a:cxnSpLocks/>
-          </p:cNvCxnSpPr>
-          <p:nvPr/>
-        </p:nvCxnSpPr>
-        <p:spPr>
-          <a:xfrm rot="16200000" flipH="1">
-            <a:off x="4902389" y="3903303"/>
-            <a:ext cx="215443" cy="2790296"/>
-          </a:xfrm>
-          <a:prstGeom prst="bentConnector3">
-            <a:avLst>
-              <a:gd name="adj1" fmla="val 347583"/>
-            </a:avLst>
-          </a:prstGeom>
-          <a:ln w="28575">
-            <a:solidFill>
-              <a:srgbClr val="10775F"/>
-            </a:solidFill>
-            <a:tailEnd type="triangle"/>
-          </a:ln>
-        </p:spPr>
-        <p:style>
-          <a:lnRef idx="1">
-            <a:schemeClr val="accent1"/>
-          </a:lnRef>
-          <a:fillRef idx="0">
-            <a:schemeClr val="accent1"/>
-          </a:fillRef>
-          <a:effectRef idx="0">
-            <a:schemeClr val="accent1"/>
-          </a:effectRef>
-          <a:fontRef idx="minor">
-            <a:schemeClr val="tx1"/>
-          </a:fontRef>
-        </p:style>
-      </p:cxnSp>
-      <p:sp>
-        <p:nvSpPr>
-          <p:cNvPr id="134" name="TextBox 133">
-            <a:extLst>
-              <a:ext uri="{FF2B5EF4-FFF2-40B4-BE49-F238E27FC236}">
-                <a16:creationId xmlns:a16="http://schemas.microsoft.com/office/drawing/2014/main" id="{F29211C2-02CB-474C-A0A7-46D9F5B68FEA}"/>
-              </a:ext>
-            </a:extLst>
-          </p:cNvPr>
-          <p:cNvSpPr txBox="1"/>
-          <p:nvPr/>
-        </p:nvSpPr>
-        <p:spPr>
-          <a:xfrm>
-            <a:off x="4331054" y="5621615"/>
-            <a:ext cx="1197764" cy="307777"/>
-          </a:xfrm>
-          <a:prstGeom prst="rect">
-            <a:avLst/>
-          </a:prstGeom>
-          <a:noFill/>
-        </p:spPr>
-        <p:txBody>
-          <a:bodyPr wrap="none" rtlCol="0">
-            <a:spAutoFit/>
-          </a:bodyPr>
-          <a:lstStyle/>
-          <a:p>
-            <a:pPr algn="ctr"/>
-            <a:r>
-              <a:rPr lang="en-DE" sz="1400" b="1" dirty="0">
-                <a:solidFill>
-                  <a:srgbClr val="10775F"/>
-                </a:solidFill>
-                <a:latin typeface="Fira Sans" panose="020B0503050000020004" pitchFamily="34" charset="0"/>
-              </a:rPr>
-              <a:t>Analyze in R</a:t>
-            </a:r>
-          </a:p>
-        </p:txBody>
-      </p:sp>
       <p:pic>
         <p:nvPicPr>
           <p:cNvPr id="2" name="Grafik 1"/>
@@ -10234,6 +9783,47 @@
           </a:prstGeom>
         </p:spPr>
       </p:pic>
+      <p:sp>
+        <p:nvSpPr>
+          <p:cNvPr id="64" name="TextBox 128">
+            <a:extLst>
+              <a:ext uri="{FF2B5EF4-FFF2-40B4-BE49-F238E27FC236}">
+                <a16:creationId xmlns:a16="http://schemas.microsoft.com/office/drawing/2014/main" id="{7C745938-4E7D-694A-8CF7-43CC993F8C00}"/>
+              </a:ext>
+            </a:extLst>
+          </p:cNvPr>
+          <p:cNvSpPr txBox="1"/>
+          <p:nvPr/>
+        </p:nvSpPr>
+        <p:spPr>
+          <a:xfrm>
+            <a:off x="6007140" y="3020130"/>
+            <a:ext cx="1438214" cy="307777"/>
+          </a:xfrm>
+          <a:prstGeom prst="rect">
+            <a:avLst/>
+          </a:prstGeom>
+          <a:noFill/>
+        </p:spPr>
+        <p:txBody>
+          <a:bodyPr wrap="none" rtlCol="0">
+            <a:spAutoFit/>
+          </a:bodyPr>
+          <a:lstStyle/>
+          <a:p>
+            <a:pPr algn="ctr"/>
+            <a:r>
+              <a:rPr lang="en-DE" sz="1400" b="1" dirty="0">
+                <a:solidFill>
+                  <a:srgbClr val="BFBCBC"/>
+                </a:solidFill>
+                <a:latin typeface="Fira Sans" panose="020B0503050000020004" pitchFamily="34" charset="0"/>
+              </a:rPr>
+              <a:t>Analyze Online</a:t>
+            </a:r>
+          </a:p>
+        </p:txBody>
+      </p:sp>
     </p:spTree>
     <p:extLst>
       <p:ext uri="{BB962C8B-B14F-4D97-AF65-F5344CB8AC3E}">

</xml_diff>